<commit_message>
feat: add Module 8 (AI System Architect) with Mermaid.js integration
</commit_message>
<xml_diff>
--- a/backend/AI_SDLC_Presentation.pptx
+++ b/backend/AI_SDLC_Presentation.pptx
@@ -3285,30 +3285,6 @@
               <a:t>Automated root cause analysis from bug reports</a:t>
             </a:r>
           </a:p>
-          <a:p>
-            <a:pPr>
-              <a:defRPr sz="2000">
-                <a:solidFill>
-                  <a:srgbClr val="FFFFFF"/>
-                </a:solidFill>
-              </a:defRPr>
-            </a:pPr>
-            <a:r>
-              <a:t>Retrieves codebase context using RAG</a:t>
-            </a:r>
-          </a:p>
-          <a:p>
-            <a:pPr>
-              <a:defRPr sz="2000">
-                <a:solidFill>
-                  <a:srgbClr val="FFFFFF"/>
-                </a:solidFill>
-              </a:defRPr>
-            </a:pPr>
-            <a:r>
-              <a:t>Generates verified code fixes with regression warnings</a:t>
-            </a:r>
-          </a:p>
           <a:p/>
           <a:p>
             <a:pPr>
@@ -3373,7 +3349,7 @@
               </a:defRPr>
             </a:pPr>
             <a:r>
-              <a:t>RAG &amp; Contextual Intelligence</a:t>
+              <a:t>Module 7: Integrations &amp; RAG</a:t>
             </a:r>
           </a:p>
         </p:txBody>
@@ -3395,50 +3371,39 @@
           <a:p/>
           <a:p>
             <a:pPr>
-              <a:defRPr sz="2200">
+              <a:defRPr sz="2000">
                 <a:solidFill>
                   <a:srgbClr val="FFFFFF"/>
                 </a:solidFill>
               </a:defRPr>
             </a:pPr>
             <a:r>
-              <a:t>Problem: AI often lacks context of the existing codebase.</a:t>
-            </a:r>
-          </a:p>
-          <a:p>
-            <a:pPr>
-              <a:defRPr sz="2200">
+              <a:t>Live GitHub and Jira Webhook data streams</a:t>
+            </a:r>
+          </a:p>
+          <a:p>
+            <a:pPr>
+              <a:defRPr sz="2000">
                 <a:solidFill>
                   <a:srgbClr val="FFFFFF"/>
                 </a:solidFill>
               </a:defRPr>
             </a:pPr>
             <a:r>
-              <a:t>Solution: Retrieval-Augmented Generation (RAG).</a:t>
-            </a:r>
-          </a:p>
-          <a:p>
-            <a:pPr>
-              <a:defRPr sz="2200">
-                <a:solidFill>
-                  <a:srgbClr val="FFFFFF"/>
-                </a:solidFill>
-              </a:defRPr>
-            </a:pPr>
-            <a:r>
-              <a:t>Implementation: Codebase is indexed into a FAISS Vector Store.</a:t>
-            </a:r>
-          </a:p>
-          <a:p>
-            <a:pPr>
-              <a:defRPr sz="2200">
-                <a:solidFill>
-                  <a:srgbClr val="FFFFFF"/>
-                </a:solidFill>
-              </a:defRPr>
-            </a:pPr>
-            <a:r>
-              <a:t>Benefit: AI makes decisions based on actual project patterns, not just generic knowledge.</a:t>
+              <a:t>Codebase indexing for context-aware AI decisions</a:t>
+            </a:r>
+          </a:p>
+          <a:p/>
+          <a:p>
+            <a:pPr>
+              <a:defRPr b="1" sz="2200">
+                <a:solidFill>
+                  <a:srgbClr val="00FF7F"/>
+                </a:solidFill>
+              </a:defRPr>
+            </a:pPr>
+            <a:r>
+              <a:t>Value: Unified source of truth for the entire SDLC.</a:t>
             </a:r>
           </a:p>
         </p:txBody>
@@ -3492,7 +3457,7 @@
               </a:defRPr>
             </a:pPr>
             <a:r>
-              <a:t>Enterprise Features (The 'Extra Mile')</a:t>
+              <a:t>Module 8: AI System Architect</a:t>
             </a:r>
           </a:p>
         </p:txBody>
@@ -3514,50 +3479,39 @@
           <a:p/>
           <a:p>
             <a:pPr>
-              <a:defRPr sz="2400">
+              <a:defRPr sz="2000">
                 <a:solidFill>
                   <a:srgbClr val="FFFFFF"/>
                 </a:solidFill>
               </a:defRPr>
             </a:pPr>
             <a:r>
-              <a:t>Real-time Integration: Live GitHub/Jira Webhook feed</a:t>
-            </a:r>
-          </a:p>
-          <a:p>
-            <a:pPr>
-              <a:defRPr sz="2400">
+              <a:t>Converts natural language into live Mermaid.js diagrams</a:t>
+            </a:r>
+          </a:p>
+          <a:p>
+            <a:pPr>
+              <a:defRPr sz="2000">
                 <a:solidFill>
                   <a:srgbClr val="FFFFFF"/>
                 </a:solidFill>
               </a:defRPr>
             </a:pPr>
             <a:r>
-              <a:t>Security: API Key Guarding and Header-based authentication</a:t>
-            </a:r>
-          </a:p>
-          <a:p>
-            <a:pPr>
-              <a:defRPr sz="2400">
-                <a:solidFill>
-                  <a:srgbClr val="FFFFFF"/>
-                </a:solidFill>
-              </a:defRPr>
-            </a:pPr>
-            <a:r>
-              <a:t>Exportability: One-click JSON/PDF/PPTX reports</a:t>
-            </a:r>
-          </a:p>
-          <a:p>
-            <a:pPr>
-              <a:defRPr sz="2400">
-                <a:solidFill>
-                  <a:srgbClr val="FFFFFF"/>
-                </a:solidFill>
-              </a:defRPr>
-            </a:pPr>
-            <a:r>
-              <a:t>Scalability: Asynchronous task processing with FastAPI</a:t>
+              <a:t>Automates architectural documentation and visualization</a:t>
+            </a:r>
+          </a:p>
+          <a:p/>
+          <a:p>
+            <a:pPr>
+              <a:defRPr b="1" sz="2200">
+                <a:solidFill>
+                  <a:srgbClr val="00FF7F"/>
+                </a:solidFill>
+              </a:defRPr>
+            </a:pPr>
+            <a:r>
+              <a:t>Value: Bridges the gap between business logic and technical design.</a:t>
             </a:r>
           </a:p>
         </p:txBody>
@@ -3998,7 +3952,7 @@
               </a:defRPr>
             </a:pPr>
             <a:r>
-              <a:t>Core: 6 specialized AI modules running on a high-performance stack.</a:t>
+              <a:t>Core: 8 specialized AI modules running on a high-performance stack.</a:t>
             </a:r>
           </a:p>
           <a:p>
@@ -4129,7 +4083,7 @@
               </a:defRPr>
             </a:pPr>
             <a:r>
-              <a:t>Knowledge: RAG Engine with FAISS Vector Store for codebase context</a:t>
+              <a:t>Knowledge: RAG Engine with FAISS Vector Store</a:t>
             </a:r>
           </a:p>
           <a:p>
@@ -4260,18 +4214,6 @@
               </a:defRPr>
             </a:pPr>
             <a:r>
-              <a:t>Flags Scope Creep and Undefined Dependencies</a:t>
-            </a:r>
-          </a:p>
-          <a:p>
-            <a:pPr>
-              <a:defRPr sz="2000">
-                <a:solidFill>
-                  <a:srgbClr val="FFFFFF"/>
-                </a:solidFill>
-              </a:defRPr>
-            </a:pPr>
-            <a:r>
               <a:t>Calculates a Completeness Score (0-100)</a:t>
             </a:r>
           </a:p>
@@ -4380,7 +4322,7 @@
               </a:defRPr>
             </a:pPr>
             <a:r>
-              <a:t>Identifies OWASP Top 10 vulnerabilities</a:t>
+              <a:t>Provides 'Before vs. After' code diffs with fixes</a:t>
             </a:r>
           </a:p>
           <a:p>
@@ -4392,19 +4334,7 @@
               </a:defRPr>
             </a:pPr>
             <a:r>
-              <a:t>Provides 'Before vs. After' code diffs with suggested fixes</a:t>
-            </a:r>
-          </a:p>
-          <a:p>
-            <a:pPr>
-              <a:defRPr sz="2000">
-                <a:solidFill>
-                  <a:srgbClr val="FFFFFF"/>
-                </a:solidFill>
-              </a:defRPr>
-            </a:pPr>
-            <a:r>
-              <a:t>Checks for missing unit tests for the changed code</a:t>
+              <a:t>Checks for missing unit tests</a:t>
             </a:r>
           </a:p>
           <a:p/>
@@ -4500,7 +4430,7 @@
               </a:defRPr>
             </a:pPr>
             <a:r>
-              <a:t>Generates full pytest / jest files from raw function bodies</a:t>
+              <a:t>Generates full pytest / jest files automatically</a:t>
             </a:r>
           </a:p>
           <a:p>
@@ -4513,18 +4443,6 @@
             </a:pPr>
             <a:r>
               <a:t>Covers edge cases (null values, boundary limits)</a:t>
-            </a:r>
-          </a:p>
-          <a:p>
-            <a:pPr>
-              <a:defRPr sz="2000">
-                <a:solidFill>
-                  <a:srgbClr val="FFFFFF"/>
-                </a:solidFill>
-              </a:defRPr>
-            </a:pPr>
-            <a:r>
-              <a:t>Prioritizes tests based on 'Regression Risk'</a:t>
             </a:r>
           </a:p>
           <a:p/>
@@ -4632,18 +4550,6 @@
               </a:defRPr>
             </a:pPr>
             <a:r>
-              <a:t>Escalates Auth changes and DB migrations</a:t>
-            </a:r>
-          </a:p>
-          <a:p>
-            <a:pPr>
-              <a:defRPr sz="2000">
-                <a:solidFill>
-                  <a:srgbClr val="FFFFFF"/>
-                </a:solidFill>
-              </a:defRPr>
-            </a:pPr>
-            <a:r>
               <a:t>Generates Rollback Plan and Monitoring Checklist</a:t>
             </a:r>
           </a:p>
@@ -4741,18 +4647,6 @@
             </a:pPr>
             <a:r>
               <a:t>Maps: Requirement → Story → Commit → Test → Deployment</a:t>
-            </a:r>
-          </a:p>
-          <a:p>
-            <a:pPr>
-              <a:defRPr sz="2000">
-                <a:solidFill>
-                  <a:srgbClr val="FFFFFF"/>
-                </a:solidFill>
-              </a:defRPr>
-            </a:pPr>
-            <a:r>
-              <a:t>Detects 'Orphaned Code' (Code with no requirement)</a:t>
             </a:r>
           </a:p>
           <a:p>

</xml_diff>